<commit_message>
docs: give the presentation cover a more professional look
Replaces the hero-graphic cover (concentric circles + car icon) with
an editorial spec-sheet layout: title/subtitle/author block on the
left, a thin divider, and a hardware/scope/milestone summary panel
on the right. Also fixes crowded title/citation spacing on the
theoretical-framework slide.

Co-Authored-By: Claude Sonnet 5 <noreply@anthropic.com>
Claude-Session: https://claude.ai/code/session_01EUcE7ADSenDaXH2xpYWH4U
</commit_message>
<xml_diff>
--- a/presentation/hito1-vrcar.pptx
+++ b/presentation/hito1-vrcar.pptx
@@ -3114,7 +3114,7 @@
         <p:spPr>
           <a:xfrm>
             <a:off x="0" y="0"/>
-            <a:ext cx="12191695" cy="128016"/>
+            <a:ext cx="63500" cy="6858000"/>
           </a:xfrm>
           <a:prstGeom prst="rect">
             <a:avLst/>
@@ -3151,20 +3151,20 @@
       </p:sp>
       <p:sp>
         <p:nvSpPr>
-          <p:cNvPr id="3" name="Oval 2"/>
+          <p:cNvPr id="3" name="Rectangle 2"/>
           <p:cNvSpPr/>
           <p:nvPr/>
         </p:nvSpPr>
         <p:spPr>
           <a:xfrm>
-            <a:off x="7985455" y="2651760"/>
-            <a:ext cx="5669280" cy="5669280"/>
-          </a:xfrm>
-          <a:prstGeom prst="ellipse">
+            <a:off x="8366760" y="822960"/>
+            <a:ext cx="12700" cy="5212080"/>
+          </a:xfrm>
+          <a:prstGeom prst="rect">
             <a:avLst/>
           </a:prstGeom>
           <a:solidFill>
-            <a:srgbClr val="111B2E"/>
+            <a:srgbClr val="27334A"/>
           </a:solidFill>
           <a:ln>
             <a:noFill/>
@@ -3195,109 +3195,101 @@
       </p:sp>
       <p:sp>
         <p:nvSpPr>
-          <p:cNvPr id="4" name="Oval 3"/>
+          <p:cNvPr id="4" name="TextBox 3"/>
+          <p:cNvSpPr txBox="1"/>
+          <p:nvPr/>
+        </p:nvSpPr>
+        <p:spPr>
+          <a:xfrm>
+            <a:off x="868680" y="822960"/>
+            <a:ext cx="6995160" cy="365760"/>
+          </a:xfrm>
+          <a:prstGeom prst="rect">
+            <a:avLst/>
+          </a:prstGeom>
+          <a:noFill/>
+        </p:spPr>
+        <p:txBody>
+          <a:bodyPr wrap="square" anchor="t" lIns="0" rIns="0" tIns="0" bIns="0">
+            <a:spAutoFit/>
+          </a:bodyPr>
+          <a:lstStyle/>
+          <a:p>
+            <a:pPr algn="l">
+              <a:spcBef>
+                <a:spcPts val="0"/>
+              </a:spcBef>
+              <a:spcAft>
+                <a:spcPts val="0"/>
+              </a:spcAft>
+            </a:pPr>
+            <a:r>
+              <a:rPr sz="1250" b="1" i="0" spc="260">
+                <a:solidFill>
+                  <a:srgbClr val="A9B4C9"/>
+                </a:solidFill>
+                <a:latin typeface="Calibri"/>
+              </a:rPr>
+              <a:t>IDI 3185 · REALIDAD EXTENDIDA</a:t>
+            </a:r>
+          </a:p>
+        </p:txBody>
+      </p:sp>
+      <p:sp>
+        <p:nvSpPr>
+          <p:cNvPr id="5" name="TextBox 4"/>
+          <p:cNvSpPr txBox="1"/>
+          <p:nvPr/>
+        </p:nvSpPr>
+        <p:spPr>
+          <a:xfrm>
+            <a:off x="868680" y="1170432"/>
+            <a:ext cx="6995160" cy="365760"/>
+          </a:xfrm>
+          <a:prstGeom prst="rect">
+            <a:avLst/>
+          </a:prstGeom>
+          <a:noFill/>
+        </p:spPr>
+        <p:txBody>
+          <a:bodyPr wrap="square" anchor="t" lIns="0" rIns="0" tIns="0" bIns="0">
+            <a:spAutoFit/>
+          </a:bodyPr>
+          <a:lstStyle/>
+          <a:p>
+            <a:pPr algn="l">
+              <a:spcBef>
+                <a:spcPts val="0"/>
+              </a:spcBef>
+              <a:spcAft>
+                <a:spcPts val="0"/>
+              </a:spcAft>
+            </a:pPr>
+            <a:r>
+              <a:rPr sz="1250" b="1" i="0" spc="260">
+                <a:solidFill>
+                  <a:srgbClr val="35D0C7"/>
+                </a:solidFill>
+                <a:latin typeface="Calibri"/>
+              </a:rPr>
+              <a:t>HITO 1 — FORMULACIÓN DEL PROYECTO</a:t>
+            </a:r>
+          </a:p>
+        </p:txBody>
+      </p:sp>
+      <p:sp>
+        <p:nvSpPr>
+          <p:cNvPr id="6" name="Rectangle 5"/>
           <p:cNvSpPr/>
           <p:nvPr/>
         </p:nvSpPr>
         <p:spPr>
           <a:xfrm>
-            <a:off x="8899855" y="3566160"/>
-            <a:ext cx="3840480" cy="3840480"/>
-          </a:xfrm>
-          <a:prstGeom prst="ellipse">
-            <a:avLst/>
-          </a:prstGeom>
-          <a:solidFill>
-            <a:srgbClr val="0B1220"/>
-          </a:solidFill>
-          <a:ln>
-            <a:noFill/>
-          </a:ln>
-          <a:effectLst/>
-        </p:spPr>
-        <p:style>
-          <a:lnRef idx="1">
-            <a:schemeClr val="accent1"/>
-          </a:lnRef>
-          <a:fillRef idx="3">
-            <a:schemeClr val="accent1"/>
-          </a:fillRef>
-          <a:effectRef idx="2">
-            <a:schemeClr val="accent1"/>
-          </a:effectRef>
-          <a:fontRef idx="minor">
-            <a:schemeClr val="lt1"/>
-          </a:fontRef>
-        </p:style>
-        <p:txBody>
-          <a:bodyPr rtlCol="0" anchor="ctr"/>
-          <a:lstStyle/>
-          <a:p>
-            <a:pPr algn="ctr"/>
-          </a:p>
-        </p:txBody>
-      </p:sp>
-      <p:sp>
-        <p:nvSpPr>
-          <p:cNvPr id="5" name="Oval 4"/>
-          <p:cNvSpPr/>
-          <p:nvPr/>
-        </p:nvSpPr>
-        <p:spPr>
-          <a:xfrm>
-            <a:off x="9357055" y="3977640"/>
-            <a:ext cx="1828800" cy="1828800"/>
-          </a:xfrm>
-          <a:prstGeom prst="ellipse">
-            <a:avLst/>
-          </a:prstGeom>
-          <a:solidFill>
-            <a:srgbClr val="111B2E"/>
-          </a:solidFill>
-          <a:ln w="19050">
-            <a:solidFill>
-              <a:srgbClr val="35D0C7"/>
-            </a:solidFill>
-          </a:ln>
-          <a:effectLst/>
-        </p:spPr>
-        <p:style>
-          <a:lnRef idx="1">
-            <a:schemeClr val="accent1"/>
-          </a:lnRef>
-          <a:fillRef idx="3">
-            <a:schemeClr val="accent1"/>
-          </a:fillRef>
-          <a:effectRef idx="2">
-            <a:schemeClr val="accent1"/>
-          </a:effectRef>
-          <a:fontRef idx="minor">
-            <a:schemeClr val="lt1"/>
-          </a:fontRef>
-        </p:style>
-        <p:txBody>
-          <a:bodyPr rtlCol="0" anchor="ctr"/>
-          <a:lstStyle/>
-          <a:p>
-            <a:pPr algn="ctr"/>
-          </a:p>
-        </p:txBody>
-      </p:sp>
-      <p:sp>
-        <p:nvSpPr>
-          <p:cNvPr id="6" name="Rounded Rectangle 5"/>
-          <p:cNvSpPr/>
-          <p:nvPr/>
-        </p:nvSpPr>
-        <p:spPr>
-          <a:xfrm>
-            <a:off x="9704527" y="4782312"/>
-            <a:ext cx="1133856" cy="384048"/>
-          </a:xfrm>
-          <a:prstGeom prst="roundRect">
-            <a:avLst>
-              <a:gd name="adj" fmla="val 50000"/>
-            </a:avLst>
+            <a:off x="868680" y="1874519"/>
+            <a:ext cx="594360" cy="38100"/>
+          </a:xfrm>
+          <a:prstGeom prst="rect">
+            <a:avLst/>
           </a:prstGeom>
           <a:solidFill>
             <a:srgbClr val="FF7A33"/>
@@ -3331,22 +3323,153 @@
       </p:sp>
       <p:sp>
         <p:nvSpPr>
-          <p:cNvPr id="7" name="Rounded Rectangle 6"/>
+          <p:cNvPr id="7" name="TextBox 6"/>
+          <p:cNvSpPr txBox="1"/>
+          <p:nvPr/>
+        </p:nvSpPr>
+        <p:spPr>
+          <a:xfrm>
+            <a:off x="868680" y="2148840"/>
+            <a:ext cx="6995160" cy="1051560"/>
+          </a:xfrm>
+          <a:prstGeom prst="rect">
+            <a:avLst/>
+          </a:prstGeom>
+          <a:noFill/>
+        </p:spPr>
+        <p:txBody>
+          <a:bodyPr wrap="square" anchor="t" lIns="0" rIns="0" tIns="0" bIns="0">
+            <a:spAutoFit/>
+          </a:bodyPr>
+          <a:lstStyle/>
+          <a:p>
+            <a:pPr algn="l">
+              <a:spcBef>
+                <a:spcPts val="0"/>
+              </a:spcBef>
+              <a:spcAft>
+                <a:spcPts val="0"/>
+              </a:spcAft>
+            </a:pPr>
+            <a:r>
+              <a:rPr sz="5800" b="1" i="0">
+                <a:solidFill>
+                  <a:srgbClr val="F4F6FB"/>
+                </a:solidFill>
+                <a:latin typeface="Calibri"/>
+              </a:rPr>
+              <a:t>VR Car</a:t>
+            </a:r>
+          </a:p>
+        </p:txBody>
+      </p:sp>
+      <p:sp>
+        <p:nvSpPr>
+          <p:cNvPr id="8" name="TextBox 7"/>
+          <p:cNvSpPr txBox="1"/>
+          <p:nvPr/>
+        </p:nvSpPr>
+        <p:spPr>
+          <a:xfrm>
+            <a:off x="868680" y="3063240"/>
+            <a:ext cx="6995160" cy="777240"/>
+          </a:xfrm>
+          <a:prstGeom prst="rect">
+            <a:avLst/>
+          </a:prstGeom>
+          <a:noFill/>
+        </p:spPr>
+        <p:txBody>
+          <a:bodyPr wrap="square" anchor="t" lIns="0" rIns="0" tIns="0" bIns="0">
+            <a:spAutoFit/>
+          </a:bodyPr>
+          <a:lstStyle/>
+          <a:p>
+            <a:pPr algn="l">
+              <a:lnSpc>
+                <a:spcPct val="125000"/>
+              </a:lnSpc>
+              <a:spcBef>
+                <a:spcPts val="0"/>
+              </a:spcBef>
+              <a:spcAft>
+                <a:spcPts val="0"/>
+              </a:spcAft>
+            </a:pPr>
+            <a:r>
+              <a:rPr sz="1750" b="0" i="1">
+                <a:solidFill>
+                  <a:srgbClr val="A9B4C9"/>
+                </a:solidFill>
+                <a:latin typeface="Calibri"/>
+              </a:rPr>
+              <a:t>Percepción a Escala Real: un simulador de conducción en
+realidad virtual</a:t>
+            </a:r>
+          </a:p>
+        </p:txBody>
+      </p:sp>
+      <p:sp>
+        <p:nvSpPr>
+          <p:cNvPr id="9" name="TextBox 8"/>
+          <p:cNvSpPr txBox="1"/>
+          <p:nvPr/>
+        </p:nvSpPr>
+        <p:spPr>
+          <a:xfrm>
+            <a:off x="868680" y="3977639"/>
+            <a:ext cx="6995160" cy="1051560"/>
+          </a:xfrm>
+          <a:prstGeom prst="rect">
+            <a:avLst/>
+          </a:prstGeom>
+          <a:noFill/>
+        </p:spPr>
+        <p:txBody>
+          <a:bodyPr wrap="square" anchor="t" lIns="0" rIns="0" tIns="0" bIns="0">
+            <a:spAutoFit/>
+          </a:bodyPr>
+          <a:lstStyle/>
+          <a:p>
+            <a:pPr algn="l">
+              <a:lnSpc>
+                <a:spcPct val="135000"/>
+              </a:lnSpc>
+              <a:spcBef>
+                <a:spcPts val="0"/>
+              </a:spcBef>
+              <a:spcAft>
+                <a:spcPts val="0"/>
+              </a:spcAft>
+            </a:pPr>
+            <a:r>
+              <a:rPr sz="1550" b="0" i="0">
+                <a:solidFill>
+                  <a:srgbClr val="A9B4C9"/>
+                </a:solidFill>
+                <a:latin typeface="Calibri"/>
+              </a:rPr>
+              <a:t>Aprender, con el propio cuerpo, el tamaño real del auto y el juicio de distancias — antes de la primera clase práctica.</a:t>
+            </a:r>
+          </a:p>
+        </p:txBody>
+      </p:sp>
+      <p:sp>
+        <p:nvSpPr>
+          <p:cNvPr id="10" name="Rectangle 9"/>
           <p:cNvSpPr/>
           <p:nvPr/>
         </p:nvSpPr>
         <p:spPr>
           <a:xfrm>
-            <a:off x="9978847" y="4581144"/>
-            <a:ext cx="585216" cy="256032"/>
-          </a:xfrm>
-          <a:prstGeom prst="roundRect">
-            <a:avLst>
-              <a:gd name="adj" fmla="val 50000"/>
-            </a:avLst>
+            <a:off x="868680" y="5257800"/>
+            <a:ext cx="6995160" cy="12700"/>
+          </a:xfrm>
+          <a:prstGeom prst="rect">
+            <a:avLst/>
           </a:prstGeom>
           <a:solidFill>
-            <a:srgbClr val="FF7A33"/>
+            <a:srgbClr val="27334A"/>
           </a:solidFill>
           <a:ln>
             <a:noFill/>
@@ -3377,102 +3500,14 @@
       </p:sp>
       <p:sp>
         <p:nvSpPr>
-          <p:cNvPr id="8" name="Oval 7"/>
-          <p:cNvSpPr/>
-          <p:nvPr/>
-        </p:nvSpPr>
-        <p:spPr>
-          <a:xfrm>
-            <a:off x="9850831" y="5056632"/>
-            <a:ext cx="219456" cy="219456"/>
-          </a:xfrm>
-          <a:prstGeom prst="ellipse">
-            <a:avLst/>
-          </a:prstGeom>
-          <a:solidFill>
-            <a:srgbClr val="0B1220"/>
-          </a:solidFill>
-          <a:ln>
-            <a:noFill/>
-          </a:ln>
-          <a:effectLst/>
-        </p:spPr>
-        <p:style>
-          <a:lnRef idx="1">
-            <a:schemeClr val="accent1"/>
-          </a:lnRef>
-          <a:fillRef idx="3">
-            <a:schemeClr val="accent1"/>
-          </a:fillRef>
-          <a:effectRef idx="2">
-            <a:schemeClr val="accent1"/>
-          </a:effectRef>
-          <a:fontRef idx="minor">
-            <a:schemeClr val="lt1"/>
-          </a:fontRef>
-        </p:style>
-        <p:txBody>
-          <a:bodyPr rtlCol="0" anchor="ctr"/>
-          <a:lstStyle/>
-          <a:p>
-            <a:pPr algn="ctr"/>
-          </a:p>
-        </p:txBody>
-      </p:sp>
-      <p:sp>
-        <p:nvSpPr>
-          <p:cNvPr id="9" name="Oval 8"/>
-          <p:cNvSpPr/>
-          <p:nvPr/>
-        </p:nvSpPr>
-        <p:spPr>
-          <a:xfrm>
-            <a:off x="10472623" y="5056632"/>
-            <a:ext cx="219456" cy="219456"/>
-          </a:xfrm>
-          <a:prstGeom prst="ellipse">
-            <a:avLst/>
-          </a:prstGeom>
-          <a:solidFill>
-            <a:srgbClr val="0B1220"/>
-          </a:solidFill>
-          <a:ln>
-            <a:noFill/>
-          </a:ln>
-          <a:effectLst/>
-        </p:spPr>
-        <p:style>
-          <a:lnRef idx="1">
-            <a:schemeClr val="accent1"/>
-          </a:lnRef>
-          <a:fillRef idx="3">
-            <a:schemeClr val="accent1"/>
-          </a:fillRef>
-          <a:effectRef idx="2">
-            <a:schemeClr val="accent1"/>
-          </a:effectRef>
-          <a:fontRef idx="minor">
-            <a:schemeClr val="lt1"/>
-          </a:fontRef>
-        </p:style>
-        <p:txBody>
-          <a:bodyPr rtlCol="0" anchor="ctr"/>
-          <a:lstStyle/>
-          <a:p>
-            <a:pPr algn="ctr"/>
-          </a:p>
-        </p:txBody>
-      </p:sp>
-      <p:sp>
-        <p:nvSpPr>
-          <p:cNvPr id="10" name="TextBox 9"/>
-          <p:cNvSpPr txBox="1"/>
-          <p:nvPr/>
-        </p:nvSpPr>
-        <p:spPr>
-          <a:xfrm>
-            <a:off x="822960" y="1417320"/>
-            <a:ext cx="7315200" cy="457200"/>
+          <p:cNvPr id="11" name="TextBox 10"/>
+          <p:cNvSpPr txBox="1"/>
+          <p:nvPr/>
+        </p:nvSpPr>
+        <p:spPr>
+          <a:xfrm>
+            <a:off x="868680" y="5486400"/>
+            <a:ext cx="6995160" cy="914400"/>
           </a:xfrm>
           <a:prstGeom prst="rect">
             <a:avLst/>
@@ -3494,69 +3529,88 @@
               </a:spcAft>
             </a:pPr>
             <a:r>
-              <a:rPr sz="1400" b="1" i="0" spc="240">
+              <a:rPr sz="1400" b="1" i="0">
+                <a:solidFill>
+                  <a:srgbClr val="F4F6FB"/>
+                </a:solidFill>
+                <a:latin typeface="Calibri"/>
+              </a:rPr>
+              <a:t>Estefanía Pakarati  ·  Emmanuel Norambuena  ·  Matías Harrison</a:t>
+            </a:r>
+          </a:p>
+          <a:p>
+            <a:pPr algn="l">
+              <a:spcBef>
+                <a:spcPts val="400"/>
+              </a:spcBef>
+              <a:spcAft>
+                <a:spcPts val="0"/>
+              </a:spcAft>
+            </a:pPr>
+            <a:r>
+              <a:rPr sz="1250" b="0" i="0">
+                <a:solidFill>
+                  <a:srgbClr val="A9B4C9"/>
+                </a:solidFill>
+                <a:latin typeface="Calibri"/>
+              </a:rPr>
+              <a:t>Pontificia Universidad Católica de Chile</a:t>
+            </a:r>
+          </a:p>
+        </p:txBody>
+      </p:sp>
+      <p:sp>
+        <p:nvSpPr>
+          <p:cNvPr id="12" name="TextBox 11"/>
+          <p:cNvSpPr txBox="1"/>
+          <p:nvPr/>
+        </p:nvSpPr>
+        <p:spPr>
+          <a:xfrm>
+            <a:off x="8869680" y="2148840"/>
+            <a:ext cx="2681935" cy="292608"/>
+          </a:xfrm>
+          <a:prstGeom prst="rect">
+            <a:avLst/>
+          </a:prstGeom>
+          <a:noFill/>
+        </p:spPr>
+        <p:txBody>
+          <a:bodyPr wrap="square" anchor="t" lIns="0" rIns="0" tIns="0" bIns="0">
+            <a:spAutoFit/>
+          </a:bodyPr>
+          <a:lstStyle/>
+          <a:p>
+            <a:pPr algn="l">
+              <a:spcBef>
+                <a:spcPts val="0"/>
+              </a:spcBef>
+              <a:spcAft>
+                <a:spcPts val="0"/>
+              </a:spcAft>
+            </a:pPr>
+            <a:r>
+              <a:rPr sz="1100" b="1" i="0" spc="200">
                 <a:solidFill>
                   <a:srgbClr val="35D0C7"/>
                 </a:solidFill>
                 <a:latin typeface="Calibri"/>
               </a:rPr>
-              <a:t>IDI 3185 · REALIDAD EXTENDIDA — HITO 1</a:t>
-            </a:r>
-          </a:p>
-        </p:txBody>
-      </p:sp>
-      <p:sp>
-        <p:nvSpPr>
-          <p:cNvPr id="11" name="TextBox 10"/>
-          <p:cNvSpPr txBox="1"/>
-          <p:nvPr/>
-        </p:nvSpPr>
-        <p:spPr>
-          <a:xfrm>
-            <a:off x="777240" y="1965960"/>
-            <a:ext cx="8778240" cy="1280160"/>
-          </a:xfrm>
-          <a:prstGeom prst="rect">
-            <a:avLst/>
-          </a:prstGeom>
-          <a:noFill/>
-        </p:spPr>
-        <p:txBody>
-          <a:bodyPr wrap="square" anchor="t" lIns="0" rIns="0" tIns="0" bIns="0">
-            <a:spAutoFit/>
-          </a:bodyPr>
-          <a:lstStyle/>
-          <a:p>
-            <a:pPr algn="l">
-              <a:spcBef>
-                <a:spcPts val="0"/>
-              </a:spcBef>
-              <a:spcAft>
-                <a:spcPts val="0"/>
-              </a:spcAft>
-            </a:pPr>
-            <a:r>
-              <a:rPr sz="6600" b="1" i="0">
-                <a:solidFill>
-                  <a:srgbClr val="F4F6FB"/>
-                </a:solidFill>
-                <a:latin typeface="Calibri"/>
-              </a:rPr>
-              <a:t>VR Car</a:t>
-            </a:r>
-          </a:p>
-        </p:txBody>
-      </p:sp>
-      <p:sp>
-        <p:nvSpPr>
-          <p:cNvPr id="12" name="TextBox 11"/>
-          <p:cNvSpPr txBox="1"/>
-          <p:nvPr/>
-        </p:nvSpPr>
-        <p:spPr>
-          <a:xfrm>
-            <a:off x="822960" y="3108960"/>
-            <a:ext cx="7589520" cy="1234440"/>
+              <a:t>HARDWARE</a:t>
+            </a:r>
+          </a:p>
+        </p:txBody>
+      </p:sp>
+      <p:sp>
+        <p:nvSpPr>
+          <p:cNvPr id="13" name="TextBox 12"/>
+          <p:cNvSpPr txBox="1"/>
+          <p:nvPr/>
+        </p:nvSpPr>
+        <p:spPr>
+          <a:xfrm>
+            <a:off x="8869680" y="2423160"/>
+            <a:ext cx="2681935" cy="457200"/>
           </a:xfrm>
           <a:prstGeom prst="rect">
             <a:avLst/>
@@ -3571,7 +3625,7 @@
           <a:p>
             <a:pPr algn="l">
               <a:lnSpc>
-                <a:spcPct val="130000"/>
+                <a:spcPct val="110000"/>
               </a:lnSpc>
               <a:spcBef>
                 <a:spcPts val="0"/>
@@ -3581,58 +3635,14 @@
               </a:spcAft>
             </a:pPr>
             <a:r>
-              <a:rPr sz="2000" b="0" i="0">
-                <a:solidFill>
-                  <a:srgbClr val="A9B4C9"/>
-                </a:solidFill>
-                <a:latin typeface="Calibri"/>
-              </a:rPr>
-              <a:t>Un simulador de conducción en realidad virtual para aprender, con el propio cuerpo, el tamaño real del auto y el juicio de distancias.</a:t>
-            </a:r>
-          </a:p>
-        </p:txBody>
-      </p:sp>
-      <p:sp>
-        <p:nvSpPr>
-          <p:cNvPr id="13" name="Rectangle 12"/>
-          <p:cNvSpPr/>
-          <p:nvPr/>
-        </p:nvSpPr>
-        <p:spPr>
-          <a:xfrm>
-            <a:off x="822960" y="4617720"/>
-            <a:ext cx="2194560" cy="25400"/>
-          </a:xfrm>
-          <a:prstGeom prst="rect">
-            <a:avLst/>
-          </a:prstGeom>
-          <a:solidFill>
-            <a:srgbClr val="FF7A33"/>
-          </a:solidFill>
-          <a:ln>
-            <a:noFill/>
-          </a:ln>
-          <a:effectLst/>
-        </p:spPr>
-        <p:style>
-          <a:lnRef idx="1">
-            <a:schemeClr val="accent1"/>
-          </a:lnRef>
-          <a:fillRef idx="3">
-            <a:schemeClr val="accent1"/>
-          </a:fillRef>
-          <a:effectRef idx="2">
-            <a:schemeClr val="accent1"/>
-          </a:effectRef>
-          <a:fontRef idx="minor">
-            <a:schemeClr val="lt1"/>
-          </a:fontRef>
-        </p:style>
-        <p:txBody>
-          <a:bodyPr rtlCol="0" anchor="ctr"/>
-          <a:lstStyle/>
-          <a:p>
-            <a:pPr algn="ctr"/>
+              <a:rPr sz="1500" b="0" i="0">
+                <a:solidFill>
+                  <a:srgbClr val="F4F6FB"/>
+                </a:solidFill>
+                <a:latin typeface="Calibri"/>
+              </a:rPr>
+              <a:t>Meta Quest 3</a:t>
+            </a:r>
           </a:p>
         </p:txBody>
       </p:sp>
@@ -3644,8 +3654,8 @@
         </p:nvSpPr>
         <p:spPr>
           <a:xfrm>
-            <a:off x="822960" y="4846320"/>
-            <a:ext cx="7315200" cy="1097280"/>
+            <a:off x="8869680" y="3108960"/>
+            <a:ext cx="2681935" cy="292608"/>
           </a:xfrm>
           <a:prstGeom prst="rect">
             <a:avLst/>
@@ -3667,32 +3677,232 @@
               </a:spcAft>
             </a:pPr>
             <a:r>
-              <a:rPr sz="1500" b="1" i="0">
+              <a:rPr sz="1100" b="1" i="0" spc="200">
+                <a:solidFill>
+                  <a:srgbClr val="35D0C7"/>
+                </a:solidFill>
+                <a:latin typeface="Calibri"/>
+              </a:rPr>
+              <a:t>MOTOR</a:t>
+            </a:r>
+          </a:p>
+        </p:txBody>
+      </p:sp>
+      <p:sp>
+        <p:nvSpPr>
+          <p:cNvPr id="15" name="TextBox 14"/>
+          <p:cNvSpPr txBox="1"/>
+          <p:nvPr/>
+        </p:nvSpPr>
+        <p:spPr>
+          <a:xfrm>
+            <a:off x="8869680" y="3383280"/>
+            <a:ext cx="2681935" cy="457200"/>
+          </a:xfrm>
+          <a:prstGeom prst="rect">
+            <a:avLst/>
+          </a:prstGeom>
+          <a:noFill/>
+        </p:spPr>
+        <p:txBody>
+          <a:bodyPr wrap="square" anchor="t" lIns="0" rIns="0" tIns="0" bIns="0">
+            <a:spAutoFit/>
+          </a:bodyPr>
+          <a:lstStyle/>
+          <a:p>
+            <a:pPr algn="l">
+              <a:lnSpc>
+                <a:spcPct val="110000"/>
+              </a:lnSpc>
+              <a:spcBef>
+                <a:spcPts val="0"/>
+              </a:spcBef>
+              <a:spcAft>
+                <a:spcPts val="0"/>
+              </a:spcAft>
+            </a:pPr>
+            <a:r>
+              <a:rPr sz="1500" b="0" i="0">
                 <a:solidFill>
                   <a:srgbClr val="F4F6FB"/>
                 </a:solidFill>
                 <a:latin typeface="Calibri"/>
               </a:rPr>
-              <a:t>Estefanía Pakarati  ·  Emmanuel Norambuena  ·  Matías Harrison</a:t>
-            </a:r>
-          </a:p>
+              <a:t>Unity · XR Interaction Toolkit</a:t>
+            </a:r>
+          </a:p>
+        </p:txBody>
+      </p:sp>
+      <p:sp>
+        <p:nvSpPr>
+          <p:cNvPr id="16" name="TextBox 15"/>
+          <p:cNvSpPr txBox="1"/>
+          <p:nvPr/>
+        </p:nvSpPr>
+        <p:spPr>
+          <a:xfrm>
+            <a:off x="8869680" y="4069080"/>
+            <a:ext cx="2681935" cy="292608"/>
+          </a:xfrm>
+          <a:prstGeom prst="rect">
+            <a:avLst/>
+          </a:prstGeom>
+          <a:noFill/>
+        </p:spPr>
+        <p:txBody>
+          <a:bodyPr wrap="square" anchor="t" lIns="0" rIns="0" tIns="0" bIns="0">
+            <a:spAutoFit/>
+          </a:bodyPr>
+          <a:lstStyle/>
           <a:p>
             <a:pPr algn="l">
               <a:spcBef>
-                <a:spcPts val="400"/>
-              </a:spcBef>
-              <a:spcAft>
-                <a:spcPts val="0"/>
-              </a:spcAft>
-            </a:pPr>
-            <a:r>
-              <a:rPr sz="1300" b="0" i="0">
-                <a:solidFill>
-                  <a:srgbClr val="A9B4C9"/>
-                </a:solidFill>
-                <a:latin typeface="Calibri"/>
-              </a:rPr>
-              <a:t>Pontificia Universidad Católica de Chile</a:t>
+                <a:spcPts val="0"/>
+              </a:spcBef>
+              <a:spcAft>
+                <a:spcPts val="0"/>
+              </a:spcAft>
+            </a:pPr>
+            <a:r>
+              <a:rPr sz="1100" b="1" i="0" spc="200">
+                <a:solidFill>
+                  <a:srgbClr val="35D0C7"/>
+                </a:solidFill>
+                <a:latin typeface="Calibri"/>
+              </a:rPr>
+              <a:t>ALCANCE</a:t>
+            </a:r>
+          </a:p>
+        </p:txBody>
+      </p:sp>
+      <p:sp>
+        <p:nvSpPr>
+          <p:cNvPr id="17" name="TextBox 16"/>
+          <p:cNvSpPr txBox="1"/>
+          <p:nvPr/>
+        </p:nvSpPr>
+        <p:spPr>
+          <a:xfrm>
+            <a:off x="8869680" y="4343400"/>
+            <a:ext cx="2681935" cy="457200"/>
+          </a:xfrm>
+          <a:prstGeom prst="rect">
+            <a:avLst/>
+          </a:prstGeom>
+          <a:noFill/>
+        </p:spPr>
+        <p:txBody>
+          <a:bodyPr wrap="square" anchor="t" lIns="0" rIns="0" tIns="0" bIns="0">
+            <a:spAutoFit/>
+          </a:bodyPr>
+          <a:lstStyle/>
+          <a:p>
+            <a:pPr algn="l">
+              <a:lnSpc>
+                <a:spcPct val="110000"/>
+              </a:lnSpc>
+              <a:spcBef>
+                <a:spcPts val="0"/>
+              </a:spcBef>
+              <a:spcAft>
+                <a:spcPts val="0"/>
+              </a:spcAft>
+            </a:pPr>
+            <a:r>
+              <a:rPr sz="1500" b="0" i="0">
+                <a:solidFill>
+                  <a:srgbClr val="F4F6FB"/>
+                </a:solidFill>
+                <a:latin typeface="Calibri"/>
+              </a:rPr>
+              <a:t>Manejo básico + escala 1:1</a:t>
+            </a:r>
+          </a:p>
+        </p:txBody>
+      </p:sp>
+      <p:sp>
+        <p:nvSpPr>
+          <p:cNvPr id="18" name="TextBox 17"/>
+          <p:cNvSpPr txBox="1"/>
+          <p:nvPr/>
+        </p:nvSpPr>
+        <p:spPr>
+          <a:xfrm>
+            <a:off x="8869680" y="5029200"/>
+            <a:ext cx="2681935" cy="292608"/>
+          </a:xfrm>
+          <a:prstGeom prst="rect">
+            <a:avLst/>
+          </a:prstGeom>
+          <a:noFill/>
+        </p:spPr>
+        <p:txBody>
+          <a:bodyPr wrap="square" anchor="t" lIns="0" rIns="0" tIns="0" bIns="0">
+            <a:spAutoFit/>
+          </a:bodyPr>
+          <a:lstStyle/>
+          <a:p>
+            <a:pPr algn="l">
+              <a:spcBef>
+                <a:spcPts val="0"/>
+              </a:spcBef>
+              <a:spcAft>
+                <a:spcPts val="0"/>
+              </a:spcAft>
+            </a:pPr>
+            <a:r>
+              <a:rPr sz="1100" b="1" i="0" spc="200">
+                <a:solidFill>
+                  <a:srgbClr val="35D0C7"/>
+                </a:solidFill>
+                <a:latin typeface="Calibri"/>
+              </a:rPr>
+              <a:t>PRÓXIMO HITO</a:t>
+            </a:r>
+          </a:p>
+        </p:txBody>
+      </p:sp>
+      <p:sp>
+        <p:nvSpPr>
+          <p:cNvPr id="19" name="TextBox 18"/>
+          <p:cNvSpPr txBox="1"/>
+          <p:nvPr/>
+        </p:nvSpPr>
+        <p:spPr>
+          <a:xfrm>
+            <a:off x="8869680" y="5303520"/>
+            <a:ext cx="2681935" cy="457200"/>
+          </a:xfrm>
+          <a:prstGeom prst="rect">
+            <a:avLst/>
+          </a:prstGeom>
+          <a:noFill/>
+        </p:spPr>
+        <p:txBody>
+          <a:bodyPr wrap="square" anchor="t" lIns="0" rIns="0" tIns="0" bIns="0">
+            <a:spAutoFit/>
+          </a:bodyPr>
+          <a:lstStyle/>
+          <a:p>
+            <a:pPr algn="l">
+              <a:lnSpc>
+                <a:spcPct val="110000"/>
+              </a:lnSpc>
+              <a:spcBef>
+                <a:spcPts val="0"/>
+              </a:spcBef>
+              <a:spcAft>
+                <a:spcPts val="0"/>
+              </a:spcAft>
+            </a:pPr>
+            <a:r>
+              <a:rPr sz="1500" b="0" i="0">
+                <a:solidFill>
+                  <a:srgbClr val="F4F6FB"/>
+                </a:solidFill>
+                <a:latin typeface="Calibri"/>
+              </a:rPr>
+              <a:t>Prototipo lo-fi, 13 oct</a:t>
             </a:r>
           </a:p>
         </p:txBody>
@@ -6464,7 +6674,7 @@
         <p:spPr>
           <a:xfrm>
             <a:off x="640080" y="2148840"/>
-            <a:ext cx="3310128" cy="3520440"/>
+            <a:ext cx="3310128" cy="3657600"/>
           </a:xfrm>
           <a:prstGeom prst="roundRect">
             <a:avLst>
@@ -6598,7 +6808,7 @@
         <p:spPr>
           <a:xfrm>
             <a:off x="896112" y="3017520"/>
-            <a:ext cx="2798064" cy="731520"/>
+            <a:ext cx="2798064" cy="777240"/>
           </a:xfrm>
           <a:prstGeom prst="rect">
             <a:avLst/>
@@ -6642,7 +6852,7 @@
         </p:nvSpPr>
         <p:spPr>
           <a:xfrm>
-            <a:off x="896112" y="3566160"/>
+            <a:off x="896112" y="3813048"/>
             <a:ext cx="2798064" cy="320040"/>
           </a:xfrm>
           <a:prstGeom prst="rect">
@@ -6684,8 +6894,8 @@
         </p:nvSpPr>
         <p:spPr>
           <a:xfrm>
-            <a:off x="896112" y="3931920"/>
-            <a:ext cx="2798064" cy="1508760"/>
+            <a:off x="896112" y="4178808"/>
+            <a:ext cx="2798064" cy="1417320"/>
           </a:xfrm>
           <a:prstGeom prst="rect">
             <a:avLst/>
@@ -6730,7 +6940,7 @@
         <p:spPr>
           <a:xfrm>
             <a:off x="4206240" y="2148840"/>
-            <a:ext cx="3310128" cy="3520440"/>
+            <a:ext cx="3310128" cy="3657600"/>
           </a:xfrm>
           <a:prstGeom prst="roundRect">
             <a:avLst>
@@ -6864,7 +7074,7 @@
         <p:spPr>
           <a:xfrm>
             <a:off x="4462272" y="3017520"/>
-            <a:ext cx="2798064" cy="731520"/>
+            <a:ext cx="2798064" cy="777240"/>
           </a:xfrm>
           <a:prstGeom prst="rect">
             <a:avLst/>
@@ -6908,7 +7118,7 @@
         </p:nvSpPr>
         <p:spPr>
           <a:xfrm>
-            <a:off x="4462272" y="3566160"/>
+            <a:off x="4462272" y="3813048"/>
             <a:ext cx="2798064" cy="320040"/>
           </a:xfrm>
           <a:prstGeom prst="rect">
@@ -6950,8 +7160,8 @@
         </p:nvSpPr>
         <p:spPr>
           <a:xfrm>
-            <a:off x="4462272" y="3931920"/>
-            <a:ext cx="2798064" cy="1508760"/>
+            <a:off x="4462272" y="4178808"/>
+            <a:ext cx="2798064" cy="1417320"/>
           </a:xfrm>
           <a:prstGeom prst="rect">
             <a:avLst/>
@@ -6996,7 +7206,7 @@
         <p:spPr>
           <a:xfrm>
             <a:off x="7772400" y="2148840"/>
-            <a:ext cx="3310128" cy="3520440"/>
+            <a:ext cx="3310128" cy="3657600"/>
           </a:xfrm>
           <a:prstGeom prst="roundRect">
             <a:avLst>
@@ -7130,7 +7340,7 @@
         <p:spPr>
           <a:xfrm>
             <a:off x="8028432" y="3017520"/>
-            <a:ext cx="2798064" cy="731520"/>
+            <a:ext cx="2798064" cy="777240"/>
           </a:xfrm>
           <a:prstGeom prst="rect">
             <a:avLst/>
@@ -7174,7 +7384,7 @@
         </p:nvSpPr>
         <p:spPr>
           <a:xfrm>
-            <a:off x="8028432" y="3566160"/>
+            <a:off x="8028432" y="3813048"/>
             <a:ext cx="2798064" cy="320040"/>
           </a:xfrm>
           <a:prstGeom prst="rect">
@@ -7216,8 +7426,8 @@
         </p:nvSpPr>
         <p:spPr>
           <a:xfrm>
-            <a:off x="8028432" y="3931920"/>
-            <a:ext cx="2798064" cy="1508760"/>
+            <a:off x="8028432" y="4178808"/>
+            <a:ext cx="2798064" cy="1417320"/>
           </a:xfrm>
           <a:prstGeom prst="rect">
             <a:avLst/>

</xml_diff>

<commit_message>
fix: repair invalid OOXML in the presentation (PowerPoint couldn't open it)
The gradient-blob shapes had two sibling <a:effectLst> elements each
(one from shadow.inherit=False, one added manually for the soft-edge
blur) — invalid per the OOXML schema. LibreOffice rendered it anyway,
which is why it looked fine here, but PowerPoint refused to open the
file. Also dropped the two text-glow effects (risked the same class
of ordering bug in run properties, and weren't visible in the
LibreOffice render anyway). Verified the fix by re-opening with
python-pptx, checking every XML part is well-formed, and confirming
zero duplicate effectLst / rPr ordering issues before committing.

Co-Authored-By: Claude Sonnet 5 <noreply@anthropic.com>
Claude-Session: https://claude.ai/code/session_01EUcE7ADSenDaXH2xpYWH4U
</commit_message>
<xml_diff>
--- a/presentation/hito1-vrcar.pptx
+++ b/presentation/hito1-vrcar.pptx
@@ -3144,7 +3144,6 @@
           <a:ln>
             <a:noFill/>
           </a:ln>
-          <a:effectLst/>
           <a:effectLst>
             <a:softEdge rad="1005840"/>
           </a:effectLst>
@@ -3210,7 +3209,6 @@
           <a:ln>
             <a:noFill/>
           </a:ln>
-          <a:effectLst/>
           <a:effectLst>
             <a:softEdge rad="1005840"/>
           </a:effectLst>
@@ -3276,7 +3274,6 @@
           <a:ln>
             <a:noFill/>
           </a:ln>
-          <a:effectLst/>
           <a:effectLst>
             <a:softEdge rad="1005840"/>
           </a:effectLst>
@@ -3559,13 +3556,6 @@
                   <a:srgbClr val="F6F5FB"/>
                 </a:solidFill>
                 <a:latin typeface="Calibri"/>
-                <a:effectLst>
-                  <a:glow rad="127000">
-                    <a:srgbClr val="8B5CF6">
-                      <a:alpha val="45000"/>
-                    </a:srgbClr>
-                  </a:glow>
-                </a:effectLst>
               </a:rPr>
               <a:t>VR Car</a:t>
             </a:r>
@@ -4181,7 +4171,6 @@
           <a:ln>
             <a:noFill/>
           </a:ln>
-          <a:effectLst/>
           <a:effectLst>
             <a:softEdge rad="1005840"/>
           </a:effectLst>
@@ -4247,7 +4236,6 @@
           <a:ln>
             <a:noFill/>
           </a:ln>
-          <a:effectLst/>
           <a:effectLst>
             <a:softEdge rad="1005840"/>
           </a:effectLst>
@@ -4313,7 +4301,6 @@
           <a:ln>
             <a:noFill/>
           </a:ln>
-          <a:effectLst/>
           <a:effectLst>
             <a:softEdge rad="1005840"/>
           </a:effectLst>
@@ -4418,13 +4405,6 @@
                   <a:srgbClr val="F6F5FB"/>
                 </a:solidFill>
                 <a:latin typeface="Calibri"/>
-                <a:effectLst>
-                  <a:glow rad="127000">
-                    <a:srgbClr val="F46FB8">
-                      <a:alpha val="45000"/>
-                    </a:srgbClr>
-                  </a:glow>
-                </a:effectLst>
               </a:rPr>
               <a:t>¿Preguntas?</a:t>
             </a:r>
@@ -4639,7 +4619,6 @@
           <a:ln>
             <a:noFill/>
           </a:ln>
-          <a:effectLst/>
           <a:effectLst>
             <a:softEdge rad="1005840"/>
           </a:effectLst>
@@ -4705,7 +4684,6 @@
           <a:ln>
             <a:noFill/>
           </a:ln>
-          <a:effectLst/>
           <a:effectLst>
             <a:softEdge rad="1005840"/>
           </a:effectLst>
@@ -5559,7 +5537,6 @@
           <a:ln>
             <a:noFill/>
           </a:ln>
-          <a:effectLst/>
           <a:effectLst>
             <a:softEdge rad="1005840"/>
           </a:effectLst>
@@ -5625,7 +5602,6 @@
           <a:ln>
             <a:noFill/>
           </a:ln>
-          <a:effectLst/>
           <a:effectLst>
             <a:softEdge rad="1005840"/>
           </a:effectLst>
@@ -6374,7 +6350,6 @@
           <a:ln>
             <a:noFill/>
           </a:ln>
-          <a:effectLst/>
           <a:effectLst>
             <a:softEdge rad="1005840"/>
           </a:effectLst>
@@ -6440,7 +6415,6 @@
           <a:ln>
             <a:noFill/>
           </a:ln>
-          <a:effectLst/>
           <a:effectLst>
             <a:softEdge rad="1005840"/>
           </a:effectLst>
@@ -7210,7 +7184,6 @@
           <a:ln>
             <a:noFill/>
           </a:ln>
-          <a:effectLst/>
           <a:effectLst>
             <a:softEdge rad="1005840"/>
           </a:effectLst>
@@ -7276,7 +7249,6 @@
           <a:ln>
             <a:noFill/>
           </a:ln>
-          <a:effectLst/>
           <a:effectLst>
             <a:softEdge rad="1005840"/>
           </a:effectLst>
@@ -8424,7 +8396,6 @@
           <a:ln>
             <a:noFill/>
           </a:ln>
-          <a:effectLst/>
           <a:effectLst>
             <a:softEdge rad="1005840"/>
           </a:effectLst>
@@ -8490,7 +8461,6 @@
           <a:ln>
             <a:noFill/>
           </a:ln>
-          <a:effectLst/>
           <a:effectLst>
             <a:softEdge rad="1005840"/>
           </a:effectLst>
@@ -9628,7 +9598,6 @@
           <a:ln>
             <a:noFill/>
           </a:ln>
-          <a:effectLst/>
           <a:effectLst>
             <a:softEdge rad="1005840"/>
           </a:effectLst>
@@ -9694,7 +9663,6 @@
           <a:ln>
             <a:noFill/>
           </a:ln>
-          <a:effectLst/>
           <a:effectLst>
             <a:softEdge rad="1005840"/>
           </a:effectLst>
@@ -10679,7 +10647,6 @@
           <a:ln>
             <a:noFill/>
           </a:ln>
-          <a:effectLst/>
           <a:effectLst>
             <a:softEdge rad="1005840"/>
           </a:effectLst>
@@ -10745,7 +10712,6 @@
           <a:ln>
             <a:noFill/>
           </a:ln>
-          <a:effectLst/>
           <a:effectLst>
             <a:softEdge rad="1005840"/>
           </a:effectLst>
@@ -11592,7 +11558,6 @@
           <a:ln>
             <a:noFill/>
           </a:ln>
-          <a:effectLst/>
           <a:effectLst>
             <a:softEdge rad="1005840"/>
           </a:effectLst>
@@ -11658,7 +11623,6 @@
           <a:ln>
             <a:noFill/>
           </a:ln>
-          <a:effectLst/>
           <a:effectLst>
             <a:softEdge rad="1005840"/>
           </a:effectLst>

</xml_diff>